<commit_message>
Fix prstDash element ordering and guard single-surface division
Co-authored-by: fosteramanda <29870948+fosteramanda@users.noreply.github.com>
</commit_message>
<xml_diff>
--- a/decks/Agents-as-Tools-Agents-as-Teammates.pptx
+++ b/decks/Agents-as-Tools-Agents-as-Teammates.pptx
@@ -7094,10 +7094,10 @@
             <a:avLst/>
           </a:prstGeom>
           <a:ln w="15875">
-            <a:prstDash val="dash"/>
             <a:solidFill>
               <a:srgbClr val="605E5C"/>
             </a:solidFill>
+            <a:prstDash val="dash"/>
             <a:tailEnd type="triangle" w="med" len="med"/>
           </a:ln>
         </p:spPr>
@@ -7131,10 +7131,10 @@
             <a:avLst/>
           </a:prstGeom>
           <a:ln w="15875">
-            <a:prstDash val="dash"/>
             <a:solidFill>
               <a:srgbClr val="605E5C"/>
             </a:solidFill>
+            <a:prstDash val="dash"/>
             <a:tailEnd type="triangle" w="med" len="med"/>
           </a:ln>
         </p:spPr>
@@ -7168,10 +7168,10 @@
             <a:avLst/>
           </a:prstGeom>
           <a:ln w="15875">
-            <a:prstDash val="dash"/>
             <a:solidFill>
               <a:srgbClr val="605E5C"/>
             </a:solidFill>
+            <a:prstDash val="dash"/>
             <a:tailEnd type="triangle" w="med" len="med"/>
           </a:ln>
         </p:spPr>
@@ -7205,10 +7205,10 @@
             <a:avLst/>
           </a:prstGeom>
           <a:ln w="15875">
-            <a:prstDash val="dash"/>
             <a:solidFill>
               <a:srgbClr val="605E5C"/>
             </a:solidFill>
+            <a:prstDash val="dash"/>
             <a:tailEnd type="triangle" w="med" len="med"/>
           </a:ln>
         </p:spPr>
@@ -7242,10 +7242,10 @@
             <a:avLst/>
           </a:prstGeom>
           <a:ln w="15875">
-            <a:prstDash val="dash"/>
             <a:solidFill>
               <a:srgbClr val="605E5C"/>
             </a:solidFill>
+            <a:prstDash val="dash"/>
             <a:tailEnd type="triangle" w="med" len="med"/>
           </a:ln>
         </p:spPr>

</xml_diff>